<commit_message>
presentazione: corretto il pptx (refusi e incoerenze, Newton-CG/Barzilai-Borwein/Nocedal e Wright/un insieme/Hessiana/Prof. Sciandrone/A.A. 2025-2026) e due riquadri fuori schermo (slide 15 parametri+loss, slide 19 tabella) + README
</commit_message>
<xml_diff>
--- a/presentazione_riformattata.pptx
+++ b/presentazione_riformattata.pptx
@@ -9573,7 +9573,7 @@
                 </a:solidFill>
                 <a:latin typeface="Calibri" panose="020F0502020204030204" pitchFamily="34" charset="0"/>
               </a:rPr>
-              <a:t>Corso di laurea in Scienze matematiche per l’intelligenza artificiale, A.A. 25/26</a:t>
+              <a:t>Corso di laurea in Scienze Matematiche per l’Intelligenza Artificiale, A.A. 2025/2026</a:t>
             </a:r>
           </a:p>
         </p:txBody>
@@ -9643,7 +9643,7 @@
                 </a:solidFill>
                 <a:latin typeface="Calibri" panose="020F0502020204030204" pitchFamily="34" charset="0"/>
               </a:rPr>
-              <a:t>Relatore: Marco Sciandrone</a:t>
+              <a:t>Relatore: Prof. Marco Sciandrone</a:t>
             </a:r>
           </a:p>
         </p:txBody>
@@ -9714,7 +9714,7 @@
                 </a:solidFill>
                 <a:latin typeface="Cambria" panose="02020202020202020204" charset="0"/>
               </a:rPr>
-              <a:t>Newton CG: Schema</a:t>
+              <a:t>Newton-CG: Schema</a:t>
             </a:r>
           </a:p>
         </p:txBody>
@@ -9815,7 +9815,7 @@
                 </a:solidFill>
                 <a:latin typeface="Cambria" panose="02020202020202020204" charset="0"/>
               </a:rPr>
-              <a:t>Newton CG L1</a:t>
+              <a:t>Newton-CG L1</a:t>
             </a:r>
           </a:p>
         </p:txBody>
@@ -13014,7 +13014,7 @@
                 </a:solidFill>
                 <a:latin typeface="Cambria" panose="02020202020202020204" charset="0"/>
               </a:rPr>
-              <a:t>Newton CG L1: Schema</a:t>
+              <a:t>Newton-CG L1: Schema</a:t>
             </a:r>
           </a:p>
         </p:txBody>
@@ -13145,7 +13145,7 @@
                 </a:solidFill>
                 <a:latin typeface="Cambria" panose="02020202020202020204" charset="0"/>
               </a:rPr>
-              <a:t>Barzilai Borwein CCV</a:t>
+              <a:t>Barzilai-Borwein CCV</a:t>
             </a:r>
           </a:p>
         </p:txBody>
@@ -14959,7 +14959,7 @@
                     </a:solidFill>
                     <a:latin typeface="Calibri" panose="02020502050305020303" pitchFamily="18" charset="0"/>
                   </a:rPr>
-                  <a:t>lo risolviamo ai minimi quadrati, possiamo trovare </a:t>
+                  <a:t>Lo risolviamo ai minimi quadrati: possiamo trovare </a:t>
                 </a:r>
                 <a14:m>
                   <m:oMath xmlns:m="http://schemas.openxmlformats.org/officeDocument/2006/math">
@@ -16172,7 +16172,7 @@
             </p:nvSpPr>
             <p:spPr>
               <a:xfrm>
-                <a:off x="9796024" y="4610100"/>
+                <a:off x="9796024" y="4198620"/>
                 <a:ext cx="2416046" cy="2591543"/>
               </a:xfrm>
               <a:prstGeom prst="rect">
@@ -16569,7 +16569,7 @@
             </p:nvSpPr>
             <p:spPr>
               <a:xfrm>
-                <a:off x="9796024" y="4610100"/>
+                <a:off x="9796024" y="4198620"/>
                 <a:ext cx="2416046" cy="2591543"/>
               </a:xfrm>
               <a:prstGeom prst="rect">
@@ -16613,7 +16613,7 @@
             </p:nvSpPr>
             <p:spPr>
               <a:xfrm>
-                <a:off x="200025" y="2620221"/>
+                <a:off x="200025" y="2208741"/>
                 <a:ext cx="10802253" cy="1894558"/>
               </a:xfrm>
               <a:prstGeom prst="rect">
@@ -18490,7 +18490,7 @@
             </p:nvSpPr>
             <p:spPr>
               <a:xfrm>
-                <a:off x="200025" y="2620221"/>
+                <a:off x="200025" y="2208741"/>
                 <a:ext cx="10802253" cy="1894558"/>
               </a:xfrm>
               <a:prstGeom prst="rect">
@@ -19911,7 +19911,7 @@
         </p:blipFill>
         <p:spPr>
           <a:xfrm>
-            <a:off x="0" y="4418619"/>
+            <a:off x="0" y="4308891"/>
             <a:ext cx="8410575" cy="2507621"/>
           </a:xfrm>
           <a:prstGeom prst="rect">
@@ -20339,7 +20339,7 @@
                     <a:effectLst/>
                     <a:latin typeface="Calibri" panose="02020502050305020303" pitchFamily="18" charset="0"/>
                   </a:rPr>
-                  <a:t> Con N ≈ 10^6 – 10^9 esempi ed m grande: il gradiente completo di J </a:t>
+                  <a:t> Con N ≈ 10^6 – 10^9 esempi e m grande: il gradiente completo di J </a:t>
                 </a:r>
                 <a:r>
                   <a:rPr lang="it-IT" sz="2000" dirty="0">
@@ -20348,7 +20348,7 @@
                     </a:solidFill>
                     <a:latin typeface="Calibri" panose="02020502050305020303" pitchFamily="18" charset="0"/>
                   </a:rPr>
-                  <a:t>costa 𝑂(N𝑚).</a:t>
+                  <a:t>costa 𝑂(N𝑚)</a:t>
                 </a:r>
                 <a:r>
                   <a:rPr lang="it-IT" sz="2000" b="1" dirty="0">
@@ -20367,7 +20367,7 @@
                     <a:effectLst/>
                     <a:latin typeface="Calibri" panose="02020502050305020303" pitchFamily="18" charset="0"/>
                   </a:rPr>
-                  <a:t>per iterazione, proibitivo</a:t>
+                  <a:t>per iterazione: proibitivo</a:t>
                 </a:r>
                 <a:r>
                   <a:rPr lang="it-IT" sz="2000" b="0" i="0" dirty="0">
@@ -23895,7 +23895,7 @@
                 </a:solidFill>
                 <a:latin typeface="Calibri" panose="020F0502020204030204" pitchFamily="34" charset="0"/>
               </a:rPr>
-              <a:t>In questo modo l’analisi teorica coprirebbe un’insieme più ampio di funzioni</a:t>
+              <a:t>In questo modo l’analisi teorica coprirebbe un insieme più ampio di funzioni</a:t>
             </a:r>
           </a:p>
           <a:p>
@@ -23911,7 +23911,7 @@
                 </a:solidFill>
                 <a:latin typeface="Cambria" panose="02020202020202020204" charset="0"/>
               </a:rPr>
-              <a:t>2. Rapporto di sottocampionamento dell'hessiana dinamico</a:t>
+              <a:t>2. Rapporto di sottocampionamento dell'Hessiana dinamico</a:t>
             </a:r>
           </a:p>
           <a:p>
@@ -23927,7 +23927,7 @@
                 </a:solidFill>
                 <a:latin typeface="Calibri" panose="020F0502020204030204" pitchFamily="34" charset="0"/>
               </a:rPr>
-              <a:t>Anziché tenere R fisso, si potrebbe aumentare quando la varianza dell’hessiana</a:t>
+              <a:t>Anziché tenere R fisso, si potrebbe aumentarlo quando la varianza dell’Hessiana cresce</a:t>
             </a:r>
           </a:p>
           <a:p>
@@ -26156,7 +26156,7 @@
                     </a:solidFill>
                     <a:latin typeface="Calibri" panose="02020502050305020303" pitchFamily="18" charset="0"/>
                   </a:rPr>
-                  <a:t> iterazioni.</a:t>
+                  <a:t> iterazioni. </a:t>
                 </a:r>
                 <a:br>
                   <a:rPr lang="it-IT" dirty="0">
@@ -29959,7 +29959,7 @@
                 </a:solidFill>
                 <a:latin typeface="Calibri" panose="02020502050305020303" pitchFamily="18" charset="0"/>
               </a:rPr>
-              <a:t>anziché la versione più debole usata dal </a:t>
+              <a:t>anziché la versione più debole usata da </a:t>
             </a:r>
             <a:r>
               <a:rPr lang="it-IT" sz="2000" dirty="0" err="1">
@@ -29968,7 +29968,7 @@
                 </a:solidFill>
                 <a:latin typeface="Calibri" panose="02020502050305020303" pitchFamily="18" charset="0"/>
               </a:rPr>
-              <a:t>Nocedal</a:t>
+              <a:t>Nocedal e Wright</a:t>
             </a:r>
             <a:r>
               <a:rPr lang="it-IT" sz="2000" dirty="0">
@@ -33106,7 +33106,7 @@
                 </a:solidFill>
                 <a:latin typeface="Calibri" panose="02020502050305020303" pitchFamily="18" charset="0"/>
               </a:rPr>
-              <a:t>Migliorata risolvendo la ricorrenza (soluzione ricorrenza, no induzione)</a:t>
+              <a:t>Migliorata risolvendo la ricorrenza (soluzione in forma chiusa, senza induzione)</a:t>
             </a:r>
           </a:p>
         </p:txBody>
@@ -33177,7 +33177,7 @@
                 </a:solidFill>
                 <a:latin typeface="Cambria" panose="02020202020202020204" charset="0"/>
               </a:rPr>
-              <a:t>Newton CG</a:t>
+              <a:t>Newton-CG</a:t>
             </a:r>
           </a:p>
         </p:txBody>

</xml_diff>

<commit_message>
presentazione: slide 8 - distanziata l equazione eps_k<=c rho^k dalla riga della PL (da 13 a 22 pt), spostate in basso equazione e riga successiva (0,12 in) in Choice e fallback + README
</commit_message>
<xml_diff>
--- a/presentazione_riformattata.pptx
+++ b/presentazione_riformattata.pptx
@@ -32190,7 +32190,7 @@
             </p:nvSpPr>
             <p:spPr>
               <a:xfrm>
-                <a:off x="240766" y="3493401"/>
+                <a:off x="240766" y="3603129"/>
                 <a:ext cx="6959726" cy="710194"/>
               </a:xfrm>
               <a:prstGeom prst="rect">
@@ -32701,7 +32701,7 @@
             </p:nvSpPr>
             <p:spPr>
               <a:xfrm>
-                <a:off x="240766" y="3493401"/>
+                <a:off x="240766" y="3603129"/>
                 <a:ext cx="6959726" cy="710194"/>
               </a:xfrm>
               <a:prstGeom prst="rect">
@@ -33085,7 +33085,7 @@
         </p:nvSpPr>
         <p:spPr>
           <a:xfrm>
-            <a:off x="240766" y="4317696"/>
+            <a:off x="240766" y="4427424"/>
             <a:ext cx="6794809" cy="369332"/>
           </a:xfrm>
           <a:prstGeom prst="rect">

</xml_diff>